<commit_message>
Proofread mmmlu slides page by page with Gemini
</commit_message>
<xml_diff>
--- a/slides/datasets-in-10-minutes-mmmlu.pptx
+++ b/slides/datasets-in-10-minutes-mmmlu.pptx
@@ -19849,7 +19849,7 @@
                           <a:ea typeface="Noto Sans CJK JP"/>
                           <a:cs typeface="Noto Sans"/>
                         </a:rPr>
-                        <a:t>Question</a:t>
+                        <a:t>先頭の無名列</a:t>
                       </a:r>
                     </a:p>
                   </a:txBody>
@@ -19902,7 +19902,7 @@
                           <a:ea typeface="Noto Sans CJK JP"/>
                           <a:cs typeface="Noto Sans"/>
                         </a:rPr>
-                        <a:t>翻訳済みの設問本文</a:t>
+                        <a:t>科目内の番号（例：95）</a:t>
                       </a:r>
                     </a:p>
                   </a:txBody>
@@ -19957,7 +19957,7 @@
                           <a:ea typeface="Noto Sans CJK JP"/>
                           <a:cs typeface="Noto Sans"/>
                         </a:rPr>
-                        <a:t>A / B / C / D</a:t>
+                        <a:t>Question</a:t>
                       </a:r>
                     </a:p>
                   </a:txBody>
@@ -20007,7 +20007,7 @@
                           <a:ea typeface="Noto Sans CJK JP"/>
                           <a:cs typeface="Noto Sans"/>
                         </a:rPr>
-                        <a:t>四つの選択肢</a:t>
+                        <a:t>翻訳済みの設問本文</a:t>
                       </a:r>
                     </a:p>
                   </a:txBody>
@@ -20059,7 +20059,7 @@
                           <a:ea typeface="Noto Sans CJK JP"/>
                           <a:cs typeface="Noto Sans"/>
                         </a:rPr>
-                        <a:t>Answer</a:t>
+                        <a:t>A / B / C / D</a:t>
                       </a:r>
                     </a:p>
                   </a:txBody>
@@ -20109,7 +20109,7 @@
                           <a:ea typeface="Noto Sans CJK JP"/>
                           <a:cs typeface="Noto Sans"/>
                         </a:rPr>
-                        <a:t>正解を表すA〜Dの記号</a:t>
+                        <a:t>四つの選択肢</a:t>
                       </a:r>
                     </a:p>
                   </a:txBody>
@@ -20161,7 +20161,7 @@
                           <a:ea typeface="Noto Sans CJK JP"/>
                           <a:cs typeface="Noto Sans"/>
                         </a:rPr>
-                        <a:t>Subject</a:t>
+                        <a:t>Answer</a:t>
                       </a:r>
                     </a:p>
                   </a:txBody>
@@ -20211,7 +20211,7 @@
                           <a:ea typeface="Noto Sans CJK JP"/>
                           <a:cs typeface="Noto Sans"/>
                         </a:rPr>
-                        <a:t>科目名（例：machine_learning）</a:t>
+                        <a:t>正解を表すA〜Dの記号</a:t>
                       </a:r>
                     </a:p>
                   </a:txBody>
@@ -20263,7 +20263,7 @@
                           <a:ea typeface="Noto Sans CJK JP"/>
                           <a:cs typeface="Noto Sans"/>
                         </a:rPr>
-                        <a:t>先頭の無名列</a:t>
+                        <a:t>Subject</a:t>
                       </a:r>
                     </a:p>
                   </a:txBody>
@@ -20316,7 +20316,7 @@
                           <a:ea typeface="Noto Sans CJK JP"/>
                           <a:cs typeface="Noto Sans"/>
                         </a:rPr>
-                        <a:t>科目内の番号（例：95）</a:t>
+                        <a:t>科目名（例：machine_learning）</a:t>
                       </a:r>
                     </a:p>
                   </a:txBody>
@@ -20578,7 +20578,7 @@
                 <a:ea typeface="Noto Sans CJK JP"/>
                 <a:cs typeface="Noto Sans"/>
               </a:rPr>
-              <a:t>後続のGlobal MMLUは、42言語の翻訳と文化依存性の注釈を公開した。米国の制度や文化的知識を要する設問などを分析する。</a:t>
+              <a:t>後続のGlobal MMLUは、42言語の翻訳と文化依存性の注釈を公開した。米国の制度や文化的知識を要する設問などを分析している。</a:t>
             </a:r>
           </a:p>
           <a:p>
@@ -21779,7 +21779,7 @@
                 <a:ea typeface="Noto Sans CJK JP"/>
                 <a:cs typeface="Noto Sans"/>
               </a:rPr>
-              <a:t>MMMLUは、英語の知識評価MMLUを専門翻訳者が14言語へ訳した、四択問題のデータセット。各言語14,042問を配布する。</a:t>
+              <a:t>MMMLUは、英語の知識評価MMLUを専門翻訳者が14言語へ訳した、四択問題のデータセット。各言語14,042問を収録している。</a:t>
             </a:r>
           </a:p>
           <a:p>

</xml_diff>

<commit_message>
Improve mmmlu answer visibility and citation wording
</commit_message>
<xml_diff>
--- a/slides/datasets-in-10-minutes-mmmlu.pptx
+++ b/slides/datasets-in-10-minutes-mmmlu.pptx
@@ -8209,7 +8209,7 @@
         <p:spPr>
           <a:xfrm>
             <a:off x="594360" y="3691297"/>
-            <a:ext cx="7955279" cy="365760"/>
+            <a:ext cx="7955279" cy="386752"/>
           </a:xfrm>
           <a:prstGeom prst="rect">
             <a:avLst/>
@@ -8224,7 +8224,7 @@
           <a:p>
             <a:pPr algn="l">
               <a:lnSpc>
-                <a:spcPct val="117000"/>
+                <a:spcPts val="2640"/>
               </a:lnSpc>
               <a:spcBef>
                 <a:spcPts val="0"/>
@@ -8241,9 +8241,9 @@
               </a:defRPr>
             </a:pPr>
             <a:r>
-              <a:rPr sz="2000" b="1" lang="ja-JP" altLang="en-US">
-                <a:solidFill>
-                  <a:srgbClr val="B13731"/>
+              <a:rPr sz="2200" b="1" lang="ja-JP" altLang="en-US">
+                <a:solidFill>
+                  <a:schemeClr val="accent1"/>
                 </a:solidFill>
                 <a:latin typeface="Noto Sans"/>
                 <a:ea typeface="Noto Sans CJK JP"/>
@@ -8777,7 +8777,7 @@
         <p:spPr>
           <a:xfrm>
             <a:off x="594360" y="3749039"/>
-            <a:ext cx="7955279" cy="365760"/>
+            <a:ext cx="7955279" cy="386617"/>
           </a:xfrm>
           <a:prstGeom prst="rect">
             <a:avLst/>
@@ -8792,7 +8792,7 @@
           <a:p>
             <a:pPr algn="l">
               <a:lnSpc>
-                <a:spcPct val="117000"/>
+                <a:spcPts val="2640"/>
               </a:lnSpc>
               <a:spcBef>
                 <a:spcPts val="0"/>
@@ -8809,9 +8809,9 @@
               </a:defRPr>
             </a:pPr>
             <a:r>
-              <a:rPr sz="2000" b="1" lang="ja-JP" altLang="en-US">
-                <a:solidFill>
-                  <a:srgbClr val="B13731"/>
+              <a:rPr sz="2200" b="1" lang="ja-JP" altLang="en-US">
+                <a:solidFill>
+                  <a:schemeClr val="accent1"/>
                 </a:solidFill>
                 <a:latin typeface="Noto Sans"/>
                 <a:ea typeface="Noto Sans CJK JP"/>
@@ -9345,7 +9345,7 @@
         <p:spPr>
           <a:xfrm>
             <a:off x="594360" y="3749039"/>
-            <a:ext cx="7955279" cy="365760"/>
+            <a:ext cx="7955279" cy="386617"/>
           </a:xfrm>
           <a:prstGeom prst="rect">
             <a:avLst/>
@@ -9360,7 +9360,7 @@
           <a:p>
             <a:pPr algn="l">
               <a:lnSpc>
-                <a:spcPct val="117000"/>
+                <a:spcPts val="2640"/>
               </a:lnSpc>
               <a:spcBef>
                 <a:spcPts val="0"/>
@@ -9377,9 +9377,9 @@
               </a:defRPr>
             </a:pPr>
             <a:r>
-              <a:rPr sz="2000" b="1" lang="ja-JP" altLang="en-US">
-                <a:solidFill>
-                  <a:srgbClr val="B13731"/>
+              <a:rPr sz="2200" b="1" lang="ja-JP" altLang="en-US">
+                <a:solidFill>
+                  <a:schemeClr val="accent1"/>
                 </a:solidFill>
                 <a:latin typeface="Noto Sans"/>
                 <a:ea typeface="Noto Sans CJK JP"/>
@@ -22813,7 +22813,7 @@
         <p:spPr>
           <a:xfrm>
             <a:off x="594360" y="3680728"/>
-            <a:ext cx="7955279" cy="365760"/>
+            <a:ext cx="7955279" cy="386526"/>
           </a:xfrm>
           <a:prstGeom prst="rect">
             <a:avLst/>
@@ -22828,7 +22828,7 @@
           <a:p>
             <a:pPr algn="l">
               <a:lnSpc>
-                <a:spcPct val="117000"/>
+                <a:spcPts val="2640"/>
               </a:lnSpc>
               <a:spcBef>
                 <a:spcPts val="0"/>
@@ -22845,9 +22845,9 @@
               </a:defRPr>
             </a:pPr>
             <a:r>
-              <a:rPr sz="2000" b="1" lang="ja-JP" altLang="en-US">
-                <a:solidFill>
-                  <a:srgbClr val="B13731"/>
+              <a:rPr sz="2200" b="1" lang="ja-JP" altLang="en-US">
+                <a:solidFill>
+                  <a:schemeClr val="accent1"/>
                 </a:solidFill>
                 <a:latin typeface="Noto Sans"/>
                 <a:ea typeface="Noto Sans CJK JP"/>
@@ -23381,7 +23381,7 @@
         <p:spPr>
           <a:xfrm>
             <a:off x="594360" y="3691297"/>
-            <a:ext cx="7955279" cy="365760"/>
+            <a:ext cx="7955279" cy="386752"/>
           </a:xfrm>
           <a:prstGeom prst="rect">
             <a:avLst/>
@@ -23396,7 +23396,7 @@
           <a:p>
             <a:pPr algn="l">
               <a:lnSpc>
-                <a:spcPct val="117000"/>
+                <a:spcPts val="2640"/>
               </a:lnSpc>
               <a:spcBef>
                 <a:spcPts val="0"/>
@@ -23413,9 +23413,9 @@
               </a:defRPr>
             </a:pPr>
             <a:r>
-              <a:rPr sz="2000" b="1" lang="ja-JP" altLang="en-US">
-                <a:solidFill>
-                  <a:srgbClr val="B13731"/>
+              <a:rPr sz="2200" b="1" lang="ja-JP" altLang="en-US">
+                <a:solidFill>
+                  <a:schemeClr val="accent1"/>
                 </a:solidFill>
                 <a:latin typeface="Noto Sans"/>
                 <a:ea typeface="Noto Sans CJK JP"/>
@@ -23949,7 +23949,7 @@
         <p:spPr>
           <a:xfrm>
             <a:off x="594360" y="3690789"/>
-            <a:ext cx="7955279" cy="365760"/>
+            <a:ext cx="7955279" cy="386549"/>
           </a:xfrm>
           <a:prstGeom prst="rect">
             <a:avLst/>
@@ -23964,7 +23964,7 @@
           <a:p>
             <a:pPr algn="l">
               <a:lnSpc>
-                <a:spcPct val="117000"/>
+                <a:spcPts val="2640"/>
               </a:lnSpc>
               <a:spcBef>
                 <a:spcPts val="0"/>
@@ -23981,9 +23981,9 @@
               </a:defRPr>
             </a:pPr>
             <a:r>
-              <a:rPr sz="2000" b="1" lang="ja-JP" altLang="en-US">
-                <a:solidFill>
-                  <a:srgbClr val="B13731"/>
+              <a:rPr sz="2200" b="1" lang="ja-JP" altLang="en-US">
+                <a:solidFill>
+                  <a:schemeClr val="accent1"/>
                 </a:solidFill>
                 <a:latin typeface="Noto Sans"/>
                 <a:ea typeface="Noto Sans CJK JP"/>
@@ -24517,7 +24517,7 @@
         <p:spPr>
           <a:xfrm>
             <a:off x="594360" y="3691297"/>
-            <a:ext cx="7955279" cy="365760"/>
+            <a:ext cx="7955279" cy="386752"/>
           </a:xfrm>
           <a:prstGeom prst="rect">
             <a:avLst/>
@@ -24532,7 +24532,7 @@
           <a:p>
             <a:pPr algn="l">
               <a:lnSpc>
-                <a:spcPct val="117000"/>
+                <a:spcPts val="2640"/>
               </a:lnSpc>
               <a:spcBef>
                 <a:spcPts val="0"/>
@@ -24549,9 +24549,9 @@
               </a:defRPr>
             </a:pPr>
             <a:r>
-              <a:rPr sz="2000" b="1" lang="ja-JP" altLang="en-US">
-                <a:solidFill>
-                  <a:srgbClr val="B13731"/>
+              <a:rPr sz="2200" b="1" lang="ja-JP" altLang="en-US">
+                <a:solidFill>
+                  <a:schemeClr val="accent1"/>
                 </a:solidFill>
                 <a:latin typeface="Noto Sans"/>
                 <a:ea typeface="Noto Sans CJK JP"/>
@@ -25085,7 +25085,7 @@
         <p:spPr>
           <a:xfrm>
             <a:off x="594360" y="3669164"/>
-            <a:ext cx="7955279" cy="365760"/>
+            <a:ext cx="7955279" cy="386572"/>
           </a:xfrm>
           <a:prstGeom prst="rect">
             <a:avLst/>
@@ -25100,7 +25100,7 @@
           <a:p>
             <a:pPr algn="l">
               <a:lnSpc>
-                <a:spcPct val="117000"/>
+                <a:spcPts val="2640"/>
               </a:lnSpc>
               <a:spcBef>
                 <a:spcPts val="0"/>
@@ -25117,9 +25117,9 @@
               </a:defRPr>
             </a:pPr>
             <a:r>
-              <a:rPr sz="2000" b="1" lang="ja-JP" altLang="en-US">
-                <a:solidFill>
-                  <a:srgbClr val="B13731"/>
+              <a:rPr sz="2200" b="1" lang="ja-JP" altLang="en-US">
+                <a:solidFill>
+                  <a:schemeClr val="accent1"/>
                 </a:solidFill>
                 <a:latin typeface="Noto Sans"/>
                 <a:ea typeface="Noto Sans CJK JP"/>
@@ -25767,7 +25767,7 @@
         <p:spPr>
           <a:xfrm>
             <a:off x="594360" y="3691297"/>
-            <a:ext cx="7955279" cy="365760"/>
+            <a:ext cx="7955279" cy="386752"/>
           </a:xfrm>
           <a:prstGeom prst="rect">
             <a:avLst/>
@@ -25782,7 +25782,7 @@
           <a:p>
             <a:pPr algn="l">
               <a:lnSpc>
-                <a:spcPct val="117000"/>
+                <a:spcPts val="2640"/>
               </a:lnSpc>
               <a:spcBef>
                 <a:spcPts val="0"/>
@@ -25799,9 +25799,9 @@
               </a:defRPr>
             </a:pPr>
             <a:r>
-              <a:rPr sz="2000" b="1" lang="ja-JP" altLang="en-US">
-                <a:solidFill>
-                  <a:srgbClr val="B13731"/>
+              <a:rPr sz="2200" b="1" lang="ja-JP" altLang="en-US">
+                <a:solidFill>
+                  <a:schemeClr val="accent1"/>
                 </a:solidFill>
                 <a:latin typeface="Noto Sans"/>
                 <a:ea typeface="Noto Sans CJK JP"/>
@@ -26335,7 +26335,7 @@
         <p:spPr>
           <a:xfrm>
             <a:off x="594360" y="3680093"/>
-            <a:ext cx="7955279" cy="365760"/>
+            <a:ext cx="7955279" cy="386437"/>
           </a:xfrm>
           <a:prstGeom prst="rect">
             <a:avLst/>
@@ -26350,7 +26350,7 @@
           <a:p>
             <a:pPr algn="l">
               <a:lnSpc>
-                <a:spcPct val="117000"/>
+                <a:spcPts val="2640"/>
               </a:lnSpc>
               <a:spcBef>
                 <a:spcPts val="0"/>
@@ -26367,9 +26367,9 @@
               </a:defRPr>
             </a:pPr>
             <a:r>
-              <a:rPr sz="2000" b="1" lang="ja-JP" altLang="en-US">
-                <a:solidFill>
-                  <a:srgbClr val="B13731"/>
+              <a:rPr sz="2200" b="1" lang="ja-JP" altLang="en-US">
+                <a:solidFill>
+                  <a:schemeClr val="accent1"/>
                 </a:solidFill>
                 <a:latin typeface="Noto Sans"/>
                 <a:ea typeface="Noto Sans CJK JP"/>
@@ -26903,7 +26903,7 @@
         <p:spPr>
           <a:xfrm>
             <a:off x="594360" y="3793282"/>
-            <a:ext cx="7955279" cy="365760"/>
+            <a:ext cx="7955279" cy="386647"/>
           </a:xfrm>
           <a:prstGeom prst="rect">
             <a:avLst/>
@@ -26918,7 +26918,7 @@
           <a:p>
             <a:pPr algn="l">
               <a:lnSpc>
-                <a:spcPct val="117000"/>
+                <a:spcPts val="2640"/>
               </a:lnSpc>
               <a:spcBef>
                 <a:spcPts val="0"/>
@@ -26935,9 +26935,9 @@
               </a:defRPr>
             </a:pPr>
             <a:r>
-              <a:rPr sz="2000" b="1" lang="ja-JP" altLang="en-US">
-                <a:solidFill>
-                  <a:srgbClr val="B13731"/>
+              <a:rPr sz="2200" b="1" lang="ja-JP" altLang="en-US">
+                <a:solidFill>
+                  <a:schemeClr val="accent1"/>
                 </a:solidFill>
                 <a:latin typeface="Noto Sans"/>
                 <a:ea typeface="Noto Sans CJK JP"/>
@@ -27471,7 +27471,7 @@
         <p:spPr>
           <a:xfrm>
             <a:off x="594360" y="3691297"/>
-            <a:ext cx="7955279" cy="365760"/>
+            <a:ext cx="7955279" cy="386752"/>
           </a:xfrm>
           <a:prstGeom prst="rect">
             <a:avLst/>
@@ -27486,7 +27486,7 @@
           <a:p>
             <a:pPr algn="l">
               <a:lnSpc>
-                <a:spcPct val="117000"/>
+                <a:spcPts val="2640"/>
               </a:lnSpc>
               <a:spcBef>
                 <a:spcPts val="0"/>
@@ -27503,9 +27503,9 @@
               </a:defRPr>
             </a:pPr>
             <a:r>
-              <a:rPr sz="2000" b="1" lang="ja-JP" altLang="en-US">
-                <a:solidFill>
-                  <a:srgbClr val="B13731"/>
+              <a:rPr sz="2200" b="1" lang="ja-JP" altLang="en-US">
+                <a:solidFill>
+                  <a:schemeClr val="accent1"/>
                 </a:solidFill>
                 <a:latin typeface="Noto Sans"/>
                 <a:ea typeface="Noto Sans CJK JP"/>
@@ -28039,7 +28039,7 @@
         <p:spPr>
           <a:xfrm>
             <a:off x="594360" y="3927193"/>
-            <a:ext cx="7955279" cy="365760"/>
+            <a:ext cx="7955279" cy="386657"/>
           </a:xfrm>
           <a:prstGeom prst="rect">
             <a:avLst/>
@@ -28054,7 +28054,7 @@
           <a:p>
             <a:pPr algn="l">
               <a:lnSpc>
-                <a:spcPct val="117000"/>
+                <a:spcPts val="2640"/>
               </a:lnSpc>
               <a:spcBef>
                 <a:spcPts val="0"/>
@@ -28071,9 +28071,9 @@
               </a:defRPr>
             </a:pPr>
             <a:r>
-              <a:rPr sz="2000" b="1" lang="ja-JP" altLang="en-US">
-                <a:solidFill>
-                  <a:srgbClr val="B13731"/>
+              <a:rPr sz="2200" b="1" lang="ja-JP" altLang="en-US">
+                <a:solidFill>
+                  <a:schemeClr val="accent1"/>
                 </a:solidFill>
                 <a:latin typeface="Noto Sans"/>
                 <a:ea typeface="Noto Sans CJK JP"/>
@@ -43255,7 +43255,7 @@
         <p:spPr>
           <a:xfrm>
             <a:off x="594360" y="3680093"/>
-            <a:ext cx="7955279" cy="365760"/>
+            <a:ext cx="7955279" cy="386437"/>
           </a:xfrm>
           <a:prstGeom prst="rect">
             <a:avLst/>
@@ -43270,7 +43270,7 @@
           <a:p>
             <a:pPr algn="l">
               <a:lnSpc>
-                <a:spcPct val="117000"/>
+                <a:spcPts val="2640"/>
               </a:lnSpc>
               <a:spcBef>
                 <a:spcPts val="0"/>
@@ -43287,9 +43287,9 @@
               </a:defRPr>
             </a:pPr>
             <a:r>
-              <a:rPr sz="2000" b="1" lang="ja-JP" altLang="en-US">
-                <a:solidFill>
-                  <a:srgbClr val="B13731"/>
+              <a:rPr sz="2200" b="1" lang="ja-JP" altLang="en-US">
+                <a:solidFill>
+                  <a:schemeClr val="accent1"/>
                 </a:solidFill>
                 <a:latin typeface="Noto Sans"/>
                 <a:ea typeface="Noto Sans CJK JP"/>
@@ -43823,7 +43823,7 @@
         <p:spPr>
           <a:xfrm>
             <a:off x="594360" y="3793282"/>
-            <a:ext cx="7955279" cy="365760"/>
+            <a:ext cx="7955279" cy="386647"/>
           </a:xfrm>
           <a:prstGeom prst="rect">
             <a:avLst/>
@@ -43838,7 +43838,7 @@
           <a:p>
             <a:pPr algn="l">
               <a:lnSpc>
-                <a:spcPct val="117000"/>
+                <a:spcPts val="2640"/>
               </a:lnSpc>
               <a:spcBef>
                 <a:spcPts val="0"/>
@@ -43855,9 +43855,9 @@
               </a:defRPr>
             </a:pPr>
             <a:r>
-              <a:rPr sz="2000" b="1" lang="ja-JP" altLang="en-US">
-                <a:solidFill>
-                  <a:srgbClr val="B13731"/>
+              <a:rPr sz="2200" b="1" lang="ja-JP" altLang="en-US">
+                <a:solidFill>
+                  <a:schemeClr val="accent1"/>
                 </a:solidFill>
                 <a:latin typeface="Noto Sans"/>
                 <a:ea typeface="Noto Sans CJK JP"/>

</xml_diff>